<commit_message>
Add project partner Abhishek Mundanat to report, slides and README
</commit_message>
<xml_diff>
--- a/presentation/yield_curve_prediction.pptx
+++ b/presentation/yield_curve_prediction.pptx
@@ -126,14 +126,14 @@
   <p:extLst>
     <p:ext uri="{521415D9-36F7-43E2-AB2F-B90AF26B5E84}">
       <p14:sectionLst xmlns:p14="http://schemas.microsoft.com/office/powerpoint/2010/main">
-        <p14:section name="Introduction" id="{38b377a2-0cc5-fb9f-7e8a-c4d60c0e57a2}">
+        <p14:section name="Introduction" id="{308d7de2-f147-58e9-c4d2-0c52402f2666}">
           <p14:sldIdLst>
             <p14:sldId id="256"/>
             <p14:sldId id="257"/>
             <p14:sldId id="258"/>
           </p14:sldIdLst>
         </p14:section>
-        <p14:section name="Data and EDA" id="{37afc571-845d-317d-cdf6-358772c56905}">
+        <p14:section name="Data and EDA" id="{b892a925-5246-c84e-8f08-c25f680b95c8}">
           <p14:sldIdLst>
             <p14:sldId id="259"/>
             <p14:sldId id="260"/>
@@ -142,13 +142,13 @@
             <p14:sldId id="263"/>
           </p14:sldIdLst>
         </p14:section>
-        <p14:section name="Models" id="{a5b20c8b-68c9-b3a2-9c5f-ab2f9c4f9ab0}">
+        <p14:section name="Models" id="{2277e994-bcf1-419a-bed3-eeebd7e0dd98}">
           <p14:sldIdLst>
             <p14:sldId id="264"/>
             <p14:sldId id="265"/>
           </p14:sldIdLst>
         </p14:section>
-        <p14:section name="Results" id="{ec3bd5bb-c7b9-abb2-a3fa-ea3f35a1414e}">
+        <p14:section name="Results" id="{6b2b34ba-bb5f-8f46-3618-c98e770e7245}">
           <p14:sldIdLst>
             <p14:sldId id="266"/>
             <p14:sldId id="267"/>
@@ -159,7 +159,7 @@
             <p14:sldId id="272"/>
           </p14:sldIdLst>
         </p14:section>
-        <p14:section name="Conclusion" id="{647b9122-0422-1b7d-e724-df0443bbda3b}">
+        <p14:section name="Conclusion" id="{f0467a5e-0407-9465-4462-0dbe5b363ad7}">
           <p14:sldIdLst>
             <p14:sldId id="273"/>
             <p14:sldId id="274"/>
@@ -925,7 +925,7 @@
           <a:p>
             <a:r>
               <a:rPr lang="en-US" dirty="0"/>
-              <a:t>Introduce yourself and the project. One sentence: we tried to predict the 1-month, 5-year and 30-year US Treasury yields one week ahead with five machine learning frameworks, and compared them on simplicity, transparency and efficacy.</a:t>
+              <a:t>Introduce yourselves (Ashwin and Abhishek) and the project. One sentence: we tried to predict the 1-month, 5-year and 30-year US Treasury yields one week ahead with five machine learning frameworks, and compared them on simplicity, transparency and efficacy.</a:t>
             </a:r>
             <a:endParaRPr lang="en-US" dirty="0"/>
           </a:p>
@@ -3356,7 +3356,21 @@
                   <a:srgbClr val="CBD5E1"/>
                 </a:solidFill>
               </a:rPr>
-              <a:t>Ashwin Anand  ·  PES1UG24AM057  ·  MLBD  ·  Department of AIML, PES University</a:t>
+              <a:t>Ashwin Anand (PES1UG24AM057)  ·  Abhishek Mundanat (PES1UG24AM012)</a:t>
+            </a:r>
+            <a:endParaRPr lang="en-US" sz="1800" dirty="0"/>
+          </a:p>
+          <a:p>
+            <a:pPr algn="l" indent="0" marL="0">
+              <a:buNone/>
+            </a:pPr>
+            <a:r>
+              <a:rPr lang="en-US" sz="1800" dirty="0">
+                <a:solidFill>
+                  <a:srgbClr val="CBD5E1"/>
+                </a:solidFill>
+              </a:rPr>
+              <a:t>MLBD  ·  Department of AIML, PES University</a:t>
             </a:r>
             <a:endParaRPr lang="en-US" sz="1800" dirty="0"/>
           </a:p>

</xml_diff>